<commit_message>
First Nebraska.Code pptx updates
</commit_message>
<xml_diff>
--- a/2026/0723_NebraskaCode/WindowsAI/Nebraska.Code - Intelligent Windows Apps with WAI.pptx
+++ b/2026/0723_NebraskaCode/WindowsAI/Nebraska.Code - Intelligent Windows Apps with WAI.pptx
@@ -1068,8 +1068,8 @@
         <a:lstStyle/>
         <a:p>
           <a:r>
-            <a:rPr lang="en-US"/>
-            <a:t>Software industry for nearly 30 years</a:t>
+            <a:rPr lang="en-US" dirty="0"/>
+            <a:t>Software industry for over 30 years</a:t>
           </a:r>
         </a:p>
       </dgm:t>
@@ -1261,13 +1261,13 @@
       <dgm:prSet presAssocID="{99F4496A-FCFF-474F-9A66-B93B851994F6}" presName="iconRect" presStyleLbl="node1" presStyleIdx="0" presStyleCnt="5"/>
       <dgm:spPr>
         <a:blipFill>
-          <a:blip xmlns:r="http://schemas.openxmlformats.org/officeDocument/2006/relationships" r:embed="rId1">
+          <a:blip xmlns:r="http://schemas.openxmlformats.org/officeDocument/2006/relationships">
             <a:extLst>
               <a:ext uri="{28A0092B-C50C-407E-A947-70E740481C1C}">
                 <a14:useLocalDpi xmlns:a14="http://schemas.microsoft.com/office/drawing/2010/main" val="0"/>
               </a:ext>
               <a:ext uri="{96DAC541-7B7A-43D3-8B79-37D633B846F1}">
-                <asvg:svgBlip xmlns:asvg="http://schemas.microsoft.com/office/drawing/2016/SVG/main" r:embed="rId2"/>
+                <asvg:svgBlip xmlns:asvg="http://schemas.microsoft.com/office/drawing/2016/SVG/main" r:embed="rId1"/>
               </a:ext>
             </a:extLst>
           </a:blip>
@@ -1314,13 +1314,13 @@
       <dgm:prSet presAssocID="{D3B1BE3D-A308-4D92-8CA4-19C92E2660A4}" presName="iconRect" presStyleLbl="node1" presStyleIdx="1" presStyleCnt="5"/>
       <dgm:spPr>
         <a:blipFill>
-          <a:blip xmlns:r="http://schemas.openxmlformats.org/officeDocument/2006/relationships" r:embed="rId3">
+          <a:blip xmlns:r="http://schemas.openxmlformats.org/officeDocument/2006/relationships">
             <a:extLst>
               <a:ext uri="{28A0092B-C50C-407E-A947-70E740481C1C}">
                 <a14:useLocalDpi xmlns:a14="http://schemas.microsoft.com/office/drawing/2010/main" val="0"/>
               </a:ext>
               <a:ext uri="{96DAC541-7B7A-43D3-8B79-37D633B846F1}">
-                <asvg:svgBlip xmlns:asvg="http://schemas.microsoft.com/office/drawing/2016/SVG/main" r:embed="rId4"/>
+                <asvg:svgBlip xmlns:asvg="http://schemas.microsoft.com/office/drawing/2016/SVG/main" r:embed="rId2"/>
               </a:ext>
             </a:extLst>
           </a:blip>
@@ -1367,13 +1367,13 @@
       <dgm:prSet presAssocID="{95E46716-39C9-480E-B63D-A192B937F430}" presName="iconRect" presStyleLbl="node1" presStyleIdx="2" presStyleCnt="5"/>
       <dgm:spPr>
         <a:blipFill>
-          <a:blip xmlns:r="http://schemas.openxmlformats.org/officeDocument/2006/relationships" r:embed="rId5">
+          <a:blip xmlns:r="http://schemas.openxmlformats.org/officeDocument/2006/relationships">
             <a:extLst>
               <a:ext uri="{28A0092B-C50C-407E-A947-70E740481C1C}">
                 <a14:useLocalDpi xmlns:a14="http://schemas.microsoft.com/office/drawing/2010/main" val="0"/>
               </a:ext>
               <a:ext uri="{96DAC541-7B7A-43D3-8B79-37D633B846F1}">
-                <asvg:svgBlip xmlns:asvg="http://schemas.microsoft.com/office/drawing/2016/SVG/main" r:embed="rId6"/>
+                <asvg:svgBlip xmlns:asvg="http://schemas.microsoft.com/office/drawing/2016/SVG/main" r:embed="rId3"/>
               </a:ext>
             </a:extLst>
           </a:blip>
@@ -1420,13 +1420,13 @@
       <dgm:prSet presAssocID="{E1F026B7-3998-4EF5-A306-FC6EC05DDCAF}" presName="iconRect" presStyleLbl="node1" presStyleIdx="3" presStyleCnt="5"/>
       <dgm:spPr>
         <a:blipFill>
-          <a:blip xmlns:r="http://schemas.openxmlformats.org/officeDocument/2006/relationships" r:embed="rId7">
+          <a:blip xmlns:r="http://schemas.openxmlformats.org/officeDocument/2006/relationships">
             <a:extLst>
               <a:ext uri="{28A0092B-C50C-407E-A947-70E740481C1C}">
                 <a14:useLocalDpi xmlns:a14="http://schemas.microsoft.com/office/drawing/2010/main" val="0"/>
               </a:ext>
               <a:ext uri="{96DAC541-7B7A-43D3-8B79-37D633B846F1}">
-                <asvg:svgBlip xmlns:asvg="http://schemas.microsoft.com/office/drawing/2016/SVG/main" r:embed="rId8"/>
+                <asvg:svgBlip xmlns:asvg="http://schemas.microsoft.com/office/drawing/2016/SVG/main" r:embed="rId4"/>
               </a:ext>
             </a:extLst>
           </a:blip>
@@ -1473,13 +1473,13 @@
       <dgm:prSet presAssocID="{AE450C8B-659E-4C4C-97A9-DC9010E5A5CC}" presName="iconRect" presStyleLbl="node1" presStyleIdx="4" presStyleCnt="5"/>
       <dgm:spPr>
         <a:blipFill>
-          <a:blip xmlns:r="http://schemas.openxmlformats.org/officeDocument/2006/relationships" r:embed="rId9">
+          <a:blip xmlns:r="http://schemas.openxmlformats.org/officeDocument/2006/relationships">
             <a:extLst>
               <a:ext uri="{28A0092B-C50C-407E-A947-70E740481C1C}">
                 <a14:useLocalDpi xmlns:a14="http://schemas.microsoft.com/office/drawing/2010/main" val="0"/>
               </a:ext>
               <a:ext uri="{96DAC541-7B7A-43D3-8B79-37D633B846F1}">
-                <asvg:svgBlip xmlns:asvg="http://schemas.microsoft.com/office/drawing/2016/SVG/main" r:embed="rId10"/>
+                <asvg:svgBlip xmlns:asvg="http://schemas.microsoft.com/office/drawing/2016/SVG/main" r:embed="rId5"/>
               </a:ext>
             </a:extLst>
           </a:blip>
@@ -1627,13 +1627,13 @@
           <a:avLst/>
         </a:prstGeom>
         <a:blipFill>
-          <a:blip xmlns:r="http://schemas.openxmlformats.org/officeDocument/2006/relationships" r:embed="rId1">
+          <a:blip xmlns:r="http://schemas.openxmlformats.org/officeDocument/2006/relationships">
             <a:extLst>
               <a:ext uri="{28A0092B-C50C-407E-A947-70E740481C1C}">
                 <a14:useLocalDpi xmlns:a14="http://schemas.microsoft.com/office/drawing/2010/main" val="0"/>
               </a:ext>
               <a:ext uri="{96DAC541-7B7A-43D3-8B79-37D633B846F1}">
-                <asvg:svgBlip xmlns:asvg="http://schemas.microsoft.com/office/drawing/2016/SVG/main" r:embed="rId2"/>
+                <asvg:svgBlip xmlns:asvg="http://schemas.microsoft.com/office/drawing/2016/SVG/main" r:embed="rId1"/>
               </a:ext>
             </a:extLst>
           </a:blip>
@@ -1712,8 +1712,8 @@
             <a:buNone/>
           </a:pPr>
           <a:r>
-            <a:rPr lang="en-US" sz="1900" kern="1200"/>
-            <a:t>Software industry for nearly 30 years</a:t>
+            <a:rPr lang="en-US" sz="1900" kern="1200" dirty="0"/>
+            <a:t>Software industry for over 30 years</a:t>
           </a:r>
         </a:p>
       </dsp:txBody>
@@ -1778,13 +1778,13 @@
           <a:avLst/>
         </a:prstGeom>
         <a:blipFill>
-          <a:blip xmlns:r="http://schemas.openxmlformats.org/officeDocument/2006/relationships" r:embed="rId3">
+          <a:blip xmlns:r="http://schemas.openxmlformats.org/officeDocument/2006/relationships">
             <a:extLst>
               <a:ext uri="{28A0092B-C50C-407E-A947-70E740481C1C}">
                 <a14:useLocalDpi xmlns:a14="http://schemas.microsoft.com/office/drawing/2010/main" val="0"/>
               </a:ext>
               <a:ext uri="{96DAC541-7B7A-43D3-8B79-37D633B846F1}">
-                <asvg:svgBlip xmlns:asvg="http://schemas.microsoft.com/office/drawing/2016/SVG/main" r:embed="rId4"/>
+                <asvg:svgBlip xmlns:asvg="http://schemas.microsoft.com/office/drawing/2016/SVG/main" r:embed="rId2"/>
               </a:ext>
             </a:extLst>
           </a:blip>
@@ -1929,13 +1929,13 @@
           <a:avLst/>
         </a:prstGeom>
         <a:blipFill>
-          <a:blip xmlns:r="http://schemas.openxmlformats.org/officeDocument/2006/relationships" r:embed="rId5">
+          <a:blip xmlns:r="http://schemas.openxmlformats.org/officeDocument/2006/relationships">
             <a:extLst>
               <a:ext uri="{28A0092B-C50C-407E-A947-70E740481C1C}">
                 <a14:useLocalDpi xmlns:a14="http://schemas.microsoft.com/office/drawing/2010/main" val="0"/>
               </a:ext>
               <a:ext uri="{96DAC541-7B7A-43D3-8B79-37D633B846F1}">
-                <asvg:svgBlip xmlns:asvg="http://schemas.microsoft.com/office/drawing/2016/SVG/main" r:embed="rId6"/>
+                <asvg:svgBlip xmlns:asvg="http://schemas.microsoft.com/office/drawing/2016/SVG/main" r:embed="rId3"/>
               </a:ext>
             </a:extLst>
           </a:blip>
@@ -2080,13 +2080,13 @@
           <a:avLst/>
         </a:prstGeom>
         <a:blipFill>
-          <a:blip xmlns:r="http://schemas.openxmlformats.org/officeDocument/2006/relationships" r:embed="rId7">
+          <a:blip xmlns:r="http://schemas.openxmlformats.org/officeDocument/2006/relationships">
             <a:extLst>
               <a:ext uri="{28A0092B-C50C-407E-A947-70E740481C1C}">
                 <a14:useLocalDpi xmlns:a14="http://schemas.microsoft.com/office/drawing/2010/main" val="0"/>
               </a:ext>
               <a:ext uri="{96DAC541-7B7A-43D3-8B79-37D633B846F1}">
-                <asvg:svgBlip xmlns:asvg="http://schemas.microsoft.com/office/drawing/2016/SVG/main" r:embed="rId8"/>
+                <asvg:svgBlip xmlns:asvg="http://schemas.microsoft.com/office/drawing/2016/SVG/main" r:embed="rId4"/>
               </a:ext>
             </a:extLst>
           </a:blip>
@@ -2231,13 +2231,13 @@
           <a:avLst/>
         </a:prstGeom>
         <a:blipFill>
-          <a:blip xmlns:r="http://schemas.openxmlformats.org/officeDocument/2006/relationships" r:embed="rId9">
+          <a:blip xmlns:r="http://schemas.openxmlformats.org/officeDocument/2006/relationships">
             <a:extLst>
               <a:ext uri="{28A0092B-C50C-407E-A947-70E740481C1C}">
                 <a14:useLocalDpi xmlns:a14="http://schemas.microsoft.com/office/drawing/2010/main" val="0"/>
               </a:ext>
               <a:ext uri="{96DAC541-7B7A-43D3-8B79-37D633B846F1}">
-                <asvg:svgBlip xmlns:asvg="http://schemas.microsoft.com/office/drawing/2016/SVG/main" r:embed="rId10"/>
+                <asvg:svgBlip xmlns:asvg="http://schemas.microsoft.com/office/drawing/2016/SVG/main" r:embed="rId5"/>
               </a:ext>
             </a:extLst>
           </a:blip>
@@ -3740,7 +3740,7 @@
           <a:p>
             <a:fld id="{73CB10F5-9066-4A54-B3E5-B7F0DC270549}" type="datetimeFigureOut">
               <a:rPr lang="en-US" smtClean="0"/>
-              <a:t>10/25/2025</a:t>
+              <a:t>7/10/2026</a:t>
             </a:fld>
             <a:endParaRPr lang="en-US"/>
           </a:p>
@@ -4053,7 +4053,15 @@
           <a:p>
             <a:r>
               <a:rPr lang="en-US" dirty="0"/>
-              <a:t>Welcome to TechBash 2025 and my session on the new Windows AI APIs in the Windows App SDK.</a:t>
+              <a:t>Welcome to </a:t>
+            </a:r>
+            <a:r>
+              <a:rPr lang="en-US" dirty="0" err="1"/>
+              <a:t>Nebraska.Code</a:t>
+            </a:r>
+            <a:r>
+              <a:rPr lang="en-US" dirty="0"/>
+              <a:t> 2026 and my session on building native Windows apps with WinUI, Foundry Local, and the Windows AI APIs in the Windows App SDK.</a:t>
             </a:r>
           </a:p>
         </p:txBody>
@@ -4566,7 +4574,7 @@
             </a:pPr>
             <a:r>
               <a:rPr lang="en-US" dirty="0"/>
-              <a:t>Windows AI Foundry encompasses the local Windows AI features and hosts local AI models.</a:t>
+              <a:t>Microsoft Foundry on Windows encompasses the local Windows AI features and Foundry Local hosts local AI models.</a:t>
             </a:r>
           </a:p>
           <a:p>
@@ -4576,7 +4584,7 @@
             </a:pPr>
             <a:r>
               <a:rPr lang="en-US" dirty="0"/>
-              <a:t>The Windows AI APIs are a set of APIs in the Windows App SDK that leverage the local Phi Silica model found on Copilot+ PCs.</a:t>
+              <a:t>The Windows AI APIs are a set of APIs in the Windows App SDK that leverage the local Phi Silica model found on Copilot+ PCs – coming soon to all modern Windows devices.</a:t>
             </a:r>
           </a:p>
           <a:p>
@@ -6007,7 +6015,7 @@
           <a:p>
             <a:fld id="{9C4DA1B5-7104-436F-9E1E-E978D03B73E0}" type="datetimeFigureOut">
               <a:rPr lang="en-US" smtClean="0"/>
-              <a:t>10/25/2025</a:t>
+              <a:t>7/10/2026</a:t>
             </a:fld>
             <a:endParaRPr lang="en-US"/>
           </a:p>
@@ -6282,7 +6290,7 @@
           <a:p>
             <a:fld id="{9C4DA1B5-7104-436F-9E1E-E978D03B73E0}" type="datetimeFigureOut">
               <a:rPr lang="en-US" smtClean="0"/>
-              <a:t>10/25/2025</a:t>
+              <a:t>7/10/2026</a:t>
             </a:fld>
             <a:endParaRPr lang="en-US"/>
           </a:p>
@@ -6476,7 +6484,7 @@
           <a:p>
             <a:fld id="{9C4DA1B5-7104-436F-9E1E-E978D03B73E0}" type="datetimeFigureOut">
               <a:rPr lang="en-US" smtClean="0"/>
-              <a:t>10/25/2025</a:t>
+              <a:t>7/10/2026</a:t>
             </a:fld>
             <a:endParaRPr lang="en-US"/>
           </a:p>
@@ -6744,7 +6752,7 @@
           <a:p>
             <a:fld id="{9C4DA1B5-7104-436F-9E1E-E978D03B73E0}" type="datetimeFigureOut">
               <a:rPr lang="en-US" smtClean="0"/>
-              <a:t>10/25/2025</a:t>
+              <a:t>7/10/2026</a:t>
             </a:fld>
             <a:endParaRPr lang="en-US"/>
           </a:p>
@@ -7076,7 +7084,7 @@
           <a:p>
             <a:fld id="{9C4DA1B5-7104-436F-9E1E-E978D03B73E0}" type="datetimeFigureOut">
               <a:rPr lang="en-US" smtClean="0"/>
-              <a:t>10/25/2025</a:t>
+              <a:t>7/10/2026</a:t>
             </a:fld>
             <a:endParaRPr lang="en-US"/>
           </a:p>
@@ -7686,7 +7694,7 @@
           <a:p>
             <a:fld id="{9C4DA1B5-7104-436F-9E1E-E978D03B73E0}" type="datetimeFigureOut">
               <a:rPr lang="en-US" smtClean="0"/>
-              <a:t>10/25/2025</a:t>
+              <a:t>7/10/2026</a:t>
             </a:fld>
             <a:endParaRPr lang="en-US"/>
           </a:p>
@@ -8533,7 +8541,7 @@
           <a:p>
             <a:fld id="{9C4DA1B5-7104-436F-9E1E-E978D03B73E0}" type="datetimeFigureOut">
               <a:rPr lang="en-US" smtClean="0"/>
-              <a:t>10/25/2025</a:t>
+              <a:t>7/10/2026</a:t>
             </a:fld>
             <a:endParaRPr lang="en-US"/>
           </a:p>
@@ -8703,7 +8711,7 @@
           <a:p>
             <a:fld id="{9C4DA1B5-7104-436F-9E1E-E978D03B73E0}" type="datetimeFigureOut">
               <a:rPr lang="en-US" smtClean="0"/>
-              <a:t>10/25/2025</a:t>
+              <a:t>7/10/2026</a:t>
             </a:fld>
             <a:endParaRPr lang="en-US"/>
           </a:p>
@@ -8883,7 +8891,7 @@
           <a:p>
             <a:fld id="{9C4DA1B5-7104-436F-9E1E-E978D03B73E0}" type="datetimeFigureOut">
               <a:rPr lang="en-US" smtClean="0"/>
-              <a:t>10/25/2025</a:t>
+              <a:t>7/10/2026</a:t>
             </a:fld>
             <a:endParaRPr lang="en-US"/>
           </a:p>
@@ -9053,7 +9061,7 @@
           <a:p>
             <a:fld id="{9C4DA1B5-7104-436F-9E1E-E978D03B73E0}" type="datetimeFigureOut">
               <a:rPr lang="en-US" smtClean="0"/>
-              <a:t>10/25/2025</a:t>
+              <a:t>7/10/2026</a:t>
             </a:fld>
             <a:endParaRPr lang="en-US"/>
           </a:p>
@@ -9297,7 +9305,7 @@
           <a:p>
             <a:fld id="{9C4DA1B5-7104-436F-9E1E-E978D03B73E0}" type="datetimeFigureOut">
               <a:rPr lang="en-US" smtClean="0"/>
-              <a:t>10/25/2025</a:t>
+              <a:t>7/10/2026</a:t>
             </a:fld>
             <a:endParaRPr lang="en-US"/>
           </a:p>
@@ -9589,7 +9597,7 @@
           <a:p>
             <a:fld id="{9C4DA1B5-7104-436F-9E1E-E978D03B73E0}" type="datetimeFigureOut">
               <a:rPr lang="en-US" smtClean="0"/>
-              <a:t>10/25/2025</a:t>
+              <a:t>7/10/2026</a:t>
             </a:fld>
             <a:endParaRPr lang="en-US"/>
           </a:p>
@@ -10027,7 +10035,7 @@
           <a:p>
             <a:fld id="{9C4DA1B5-7104-436F-9E1E-E978D03B73E0}" type="datetimeFigureOut">
               <a:rPr lang="en-US" smtClean="0"/>
-              <a:t>10/25/2025</a:t>
+              <a:t>7/10/2026</a:t>
             </a:fld>
             <a:endParaRPr lang="en-US"/>
           </a:p>
@@ -10145,7 +10153,7 @@
           <a:p>
             <a:fld id="{9C4DA1B5-7104-436F-9E1E-E978D03B73E0}" type="datetimeFigureOut">
               <a:rPr lang="en-US" smtClean="0"/>
-              <a:t>10/25/2025</a:t>
+              <a:t>7/10/2026</a:t>
             </a:fld>
             <a:endParaRPr lang="en-US"/>
           </a:p>
@@ -10240,7 +10248,7 @@
           <a:p>
             <a:fld id="{9C4DA1B5-7104-436F-9E1E-E978D03B73E0}" type="datetimeFigureOut">
               <a:rPr lang="en-US" smtClean="0"/>
-              <a:t>10/25/2025</a:t>
+              <a:t>7/10/2026</a:t>
             </a:fld>
             <a:endParaRPr lang="en-US"/>
           </a:p>
@@ -10519,7 +10527,7 @@
           <a:p>
             <a:fld id="{9C4DA1B5-7104-436F-9E1E-E978D03B73E0}" type="datetimeFigureOut">
               <a:rPr lang="en-US" smtClean="0"/>
-              <a:t>10/25/2025</a:t>
+              <a:t>7/10/2026</a:t>
             </a:fld>
             <a:endParaRPr lang="en-US"/>
           </a:p>
@@ -10794,7 +10802,7 @@
           <a:p>
             <a:fld id="{9C4DA1B5-7104-436F-9E1E-E978D03B73E0}" type="datetimeFigureOut">
               <a:rPr lang="en-US" smtClean="0"/>
-              <a:t>10/25/2025</a:t>
+              <a:t>7/10/2026</a:t>
             </a:fld>
             <a:endParaRPr lang="en-US"/>
           </a:p>
@@ -11237,7 +11245,7 @@
           <a:p>
             <a:fld id="{9C4DA1B5-7104-436F-9E1E-E978D03B73E0}" type="datetimeFigureOut">
               <a:rPr lang="en-US" smtClean="0"/>
-              <a:t>10/25/2025</a:t>
+              <a:t>7/10/2026</a:t>
             </a:fld>
             <a:endParaRPr lang="en-US"/>
           </a:p>
@@ -11906,7 +11914,7 @@
             </a:pPr>
             <a:r>
               <a:rPr lang="en-US" sz="5600" dirty="0"/>
-              <a:t>Build intelligent apps with WinUI, Windows AI Foundry &amp; Windows AI APIs</a:t>
+              <a:t>Build intelligent apps with WinUI, Foundry Local &amp; Windows AI APIs</a:t>
             </a:r>
           </a:p>
         </p:txBody>
@@ -15459,7 +15467,7 @@
             <p:ph idx="1"/>
             <p:extLst>
               <p:ext uri="{D42A27DB-BD31-4B8C-83A1-F6EECF244321}">
-                <p14:modId xmlns:p14="http://schemas.microsoft.com/office/powerpoint/2010/main" val="144993909"/>
+                <p14:modId xmlns:p14="http://schemas.microsoft.com/office/powerpoint/2010/main" val="2657591242"/>
               </p:ext>
             </p:extLst>
           </p:nvPr>
@@ -15681,12 +15689,12 @@
         <p:spPr>
           <a:xfrm>
             <a:off x="5282381" y="2438400"/>
-            <a:ext cx="4767471" cy="3809999"/>
+            <a:ext cx="6123038" cy="3809999"/>
           </a:xfrm>
         </p:spPr>
         <p:txBody>
           <a:bodyPr>
-            <a:normAutofit lnSpcReduction="10000"/>
+            <a:normAutofit/>
           </a:bodyPr>
           <a:lstStyle/>
           <a:p>
@@ -15697,7 +15705,7 @@
             </a:pPr>
             <a:r>
               <a:rPr lang="en-US" sz="1900" dirty="0"/>
-              <a:t>AI Options for .NET Developers</a:t>
+              <a:t>AI Options for .NET Developers on Windows</a:t>
             </a:r>
           </a:p>
           <a:p>
@@ -15719,7 +15727,7 @@
             </a:pPr>
             <a:r>
               <a:rPr lang="en-US" sz="1900" dirty="0"/>
-              <a:t>Copilot+ PCs, Windows AI Foundry, and Phi Silica</a:t>
+              <a:t>Copilot+ PCs, Foundry Local, and Phi Silica</a:t>
             </a:r>
           </a:p>
           <a:p>
@@ -16210,7 +16218,7 @@
         <p:spPr>
           <a:xfrm>
             <a:off x="648931" y="2141622"/>
-            <a:ext cx="4166509" cy="4499810"/>
+            <a:ext cx="4558288" cy="4499810"/>
           </a:xfrm>
         </p:spPr>
         <p:txBody>
@@ -16221,13 +16229,21 @@
           <a:p>
             <a:r>
               <a:rPr lang="en-US" dirty="0"/>
-              <a:t>Microsoft.Extensions.AI libraries for .NET.</a:t>
+              <a:t>Microsoft.Extensions.AI library (MEAI).</a:t>
             </a:r>
           </a:p>
           <a:p>
             <a:r>
               <a:rPr lang="en-US" dirty="0"/>
-              <a:t>Semantic Kernel – Build agents and consume models with C#, Python or Java.</a:t>
+              <a:t>Microsoft Agent Framework – Build agents and consume models with C# or Python </a:t>
+            </a:r>
+            <a:r>
+              <a:rPr lang="en-US" b="1" dirty="0"/>
+              <a:t>or</a:t>
+            </a:r>
+            <a:r>
+              <a:rPr lang="en-US" dirty="0"/>
+              <a:t> use Copilot SDK for a ready-made harness.</a:t>
             </a:r>
           </a:p>
           <a:p>
@@ -16239,19 +16255,19 @@
           <a:p>
             <a:r>
               <a:rPr lang="en-US" dirty="0"/>
-              <a:t>AI Toolkit for VS Code.</a:t>
+              <a:t>Foundry Toolkit for VS Code.</a:t>
             </a:r>
           </a:p>
           <a:p>
             <a:r>
               <a:rPr lang="en-US" dirty="0"/>
-              <a:t>GitHub Copilot in Visual Studio and VS Code.</a:t>
+              <a:t>GitHub Copilot in Visual Studio, VS Code, and the CLI.</a:t>
             </a:r>
           </a:p>
           <a:p>
             <a:r>
               <a:rPr lang="en-US" dirty="0"/>
-              <a:t>Azure AI Foundry &amp; Windows AI Foundry</a:t>
+              <a:t>Microsoft Foundry &amp; Foundry Local</a:t>
             </a:r>
           </a:p>
           <a:p>

</xml_diff>